<commit_message>
Store docs: add TV-verified player screenshots and checklist results
- UX scenario: real player and on-screen subtitle screenshots from an
  LG 55SK7900 (2018)
- Self-checklist: wheel, EXIT, BACK, color keys, language switch and
  relaunch verified on the TV

Co-Authored-By: Claude Opus 5.5 <noreply@anthropic.com>
</commit_message>
<xml_diff>
--- a/store/ux_scenario_velvo.pptx
+++ b/store/ux_scenario_velvo.pptx
@@ -23,6 +23,7 @@
     <p:sldId id="271" r:id="rId22"/>
     <p:sldId id="272" r:id="rId23"/>
     <p:sldId id="273" r:id="rId24"/>
+    <p:sldId id="274" r:id="rId25"/>
   </p:sldIdLst>
   <p:sldSz cx="12191695" cy="6858000" type="screen4x3"/>
   <p:notesSz cx="6858000" cy="9144000"/>
@@ -4611,12 +4612,20 @@
           </a:p>
         </p:txBody>
       </p:sp>
-      <p:sp>
-        <p:nvSpPr>
-          <p:cNvPr id="6" name="Rectangle 5"/>
-          <p:cNvSpPr/>
-          <p:nvPr/>
-        </p:nvSpPr>
+      <p:pic>
+        <p:nvPicPr>
+          <p:cNvPr id="6" name="Picture 5" descr="a-player.png"/>
+          <p:cNvPicPr>
+            <a:picLocks noChangeAspect="1"/>
+          </p:cNvPicPr>
+          <p:nvPr/>
+        </p:nvPicPr>
+        <p:blipFill>
+          <a:blip r:embed="rId2"/>
+          <a:stretch>
+            <a:fillRect/>
+          </a:stretch>
+        </p:blipFill>
         <p:spPr>
           <a:xfrm>
             <a:off x="365760" y="1143000"/>
@@ -4625,46 +4634,8 @@
           <a:prstGeom prst="rect">
             <a:avLst/>
           </a:prstGeom>
-          <a:solidFill>
-            <a:srgbClr val="111116"/>
-          </a:solidFill>
-          <a:ln>
-            <a:solidFill>
-              <a:srgbClr val="E6005C"/>
-            </a:solidFill>
-          </a:ln>
-        </p:spPr>
-        <p:style>
-          <a:lnRef idx="1">
-            <a:schemeClr val="accent1"/>
-          </a:lnRef>
-          <a:fillRef idx="3">
-            <a:schemeClr val="accent1"/>
-          </a:fillRef>
-          <a:effectRef idx="2">
-            <a:schemeClr val="accent1"/>
-          </a:effectRef>
-          <a:fontRef idx="minor">
-            <a:schemeClr val="lt1"/>
-          </a:fontRef>
-        </p:style>
-        <p:txBody>
-          <a:bodyPr rtlCol="0" anchor="ctr"/>
-          <a:lstStyle/>
-          <a:p>
-            <a:pPr algn="ctr">
-              <a:defRPr sz="1600">
-                <a:solidFill>
-                  <a:srgbClr val="9999A0"/>
-                </a:solidFill>
-              </a:defRPr>
-            </a:pPr>
-            <a:r>
-              <a:t>[Player screenshot from the TV]</a:t>
-            </a:r>
-          </a:p>
-        </p:txBody>
-      </p:sp>
+        </p:spPr>
+      </p:pic>
       <p:graphicFrame>
         <p:nvGraphicFramePr>
           <p:cNvPr id="7" name="Table 6"/>
@@ -4926,7 +4897,7 @@
                         </a:defRPr>
                       </a:pPr>
                       <a:r>
-                        <a:t>Audio: list of audio tracks</a:t>
+                        <a:t>Audio: list of audio tracks in the video</a:t>
                       </a:r>
                     </a:p>
                   </a:txBody>
@@ -4976,7 +4947,7 @@
                         </a:defRPr>
                       </a:pPr>
                       <a:r>
-                        <a:t>Subtitles: Off + subtitle tracks, and Size, Color, Position (◀ ▶)</a:t>
+                        <a:t>Subtitles button: shows the selected subtitle language</a:t>
                       </a:r>
                     </a:p>
                   </a:txBody>
@@ -5026,7 +4997,7 @@
                         </a:defRPr>
                       </a:pPr>
                       <a:r>
-                        <a:t>Next episode (series only)</a:t>
+                        <a:t>Subtitle list: Off + embedded subtitle tracks (✓ = selected); below the list: Size, Color, Position (◀ ▶)</a:t>
                       </a:r>
                     </a:p>
                   </a:txBody>
@@ -5076,7 +5047,7 @@
                         </a:defRPr>
                       </a:pPr>
                       <a:r>
-                        <a:t>Seek bar with elapsed and total time</a:t>
+                        <a:t>Seek bar with elapsed and remaining time</a:t>
                       </a:r>
                     </a:p>
                   </a:txBody>
@@ -5100,7 +5071,7 @@
         <p:spPr>
           <a:xfrm>
             <a:off x="365760" y="5166360"/>
-            <a:ext cx="11430000" cy="1554480"/>
+            <a:ext cx="6949440" cy="1463040"/>
           </a:xfrm>
           <a:prstGeom prst="rect">
             <a:avLst/>
@@ -5125,7 +5096,7 @@
               </a:defRPr>
             </a:pPr>
             <a:r>
-              <a:t>Keys: any key shows the control bar · OK on ⏯ pauses/resumes · ◀ ▶ seek 10 s while the bar is hidden · YELLOW = next audio track · BLUE = next subtitle track · PLAY, PAUSE, STOP, FF, REW media keys · CH+ / CH− change channel in live TV.</a:t>
+              <a:t>Screenshot taken on an LG 55SK7900 while playing "Sintel" from the demo playlist. Series episodes also show a "Next episode" button.</a:t>
             </a:r>
           </a:p>
           <a:p>
@@ -5141,7 +5112,7 @@
               </a:defRPr>
             </a:pPr>
             <a:r>
-              <a:t>BACK closes an open popup first, then leaves the player and returns to the previous page.</a:t>
+              <a:t>Keys: any key shows the control bar · OK on ⏯ pauses/resumes · ◀ ▶ seek 10 s while the bar is hidden · YELLOW = next audio track · BLUE = next subtitle track · PLAY, PAUSE, STOP, FF, REW · CH+ / CH− change channel in live TV · BACK closes an open popup first, then leaves the player.</a:t>
             </a:r>
           </a:p>
         </p:txBody>
@@ -5323,14 +5294,14 @@
               </a:defRPr>
             </a:pPr>
             <a:r>
-              <a:t>6-5 Live TV</a:t>
+              <a:t>6-4 Player: subtitles on screen</a:t>
             </a:r>
           </a:p>
         </p:txBody>
       </p:sp>
       <p:pic>
         <p:nvPicPr>
-          <p:cNvPr id="6" name="Picture 5" descr="a-live.png"/>
+          <p:cNvPr id="6" name="Picture 5" descr="tv-sub-en.png"/>
           <p:cNvPicPr>
             <a:picLocks noChangeAspect="1"/>
           </p:cNvPicPr>
@@ -5344,190 +5315,38 @@
         </p:blipFill>
         <p:spPr>
           <a:xfrm>
-            <a:off x="365760" y="1143000"/>
-            <a:ext cx="6949440" cy="3909060"/>
+            <a:off x="365760" y="1188720"/>
+            <a:ext cx="5669280" cy="3188970"/>
           </a:xfrm>
           <a:prstGeom prst="rect">
             <a:avLst/>
           </a:prstGeom>
         </p:spPr>
       </p:pic>
-      <p:graphicFrame>
-        <p:nvGraphicFramePr>
-          <p:cNvPr id="7" name="Table 6"/>
-          <p:cNvGraphicFramePr>
-            <a:graphicFrameLocks noGrp="1"/>
-          </p:cNvGraphicFramePr>
-          <p:nvPr/>
-        </p:nvGraphicFramePr>
-        <p:xfrm>
-          <a:off x="7543800" y="1143000"/>
-          <a:ext cx="4297680" cy="822959"/>
-        </p:xfrm>
-        <a:graphic>
-          <a:graphicData uri="http://schemas.openxmlformats.org/drawingml/2006/table">
-            <a:tbl>
-              <a:tblPr firstRow="1" bandRow="1">
-                <a:tableStyleId>{5C22544A-7EE6-4342-B048-85BDC9FD1C3A}</a:tableStyleId>
-              </a:tblPr>
-              <a:tblGrid>
-                <a:gridCol w="502920"/>
-                <a:gridCol w="3794760"/>
-              </a:tblGrid>
-              <a:tr h="274319">
-                <a:tc>
-                  <a:txBody>
-                    <a:bodyPr/>
-                    <a:lstStyle/>
-                    <a:p>
-                      <a:pPr>
-                        <a:defRPr sz="1050" b="1">
-                          <a:solidFill>
-                            <a:srgbClr val="FFFFFF"/>
-                          </a:solidFill>
-                          <a:latin typeface="Arial"/>
-                        </a:defRPr>
-                      </a:pPr>
-                      <a:r>
-                        <a:t>No.</a:t>
-                      </a:r>
-                    </a:p>
-                  </a:txBody>
-                  <a:tcPr>
-                    <a:solidFill>
-                      <a:srgbClr val="E6005C"/>
-                    </a:solidFill>
-                  </a:tcPr>
-                </a:tc>
-                <a:tc>
-                  <a:txBody>
-                    <a:bodyPr/>
-                    <a:lstStyle/>
-                    <a:p>
-                      <a:pPr>
-                        <a:defRPr sz="1050" b="1">
-                          <a:solidFill>
-                            <a:srgbClr val="FFFFFF"/>
-                          </a:solidFill>
-                          <a:latin typeface="Arial"/>
-                        </a:defRPr>
-                      </a:pPr>
-                      <a:r>
-                        <a:t>Description</a:t>
-                      </a:r>
-                    </a:p>
-                  </a:txBody>
-                  <a:tcPr>
-                    <a:solidFill>
-                      <a:srgbClr val="E6005C"/>
-                    </a:solidFill>
-                  </a:tcPr>
-                </a:tc>
-              </a:tr>
-              <a:tr h="274319">
-                <a:tc>
-                  <a:txBody>
-                    <a:bodyPr/>
-                    <a:lstStyle/>
-                    <a:p>
-                      <a:pPr>
-                        <a:defRPr sz="1050">
-                          <a:solidFill>
-                            <a:srgbClr val="1C0812"/>
-                          </a:solidFill>
-                          <a:latin typeface="Arial"/>
-                        </a:defRPr>
-                      </a:pPr>
-                      <a:r>
-                        <a:t>1</a:t>
-                      </a:r>
-                    </a:p>
-                  </a:txBody>
-                  <a:tcPr marT="30000" marB="30000">
-                    <a:solidFill>
-                      <a:srgbClr val="F6F1F4"/>
-                    </a:solidFill>
-                  </a:tcPr>
-                </a:tc>
-                <a:tc>
-                  <a:txBody>
-                    <a:bodyPr/>
-                    <a:lstStyle/>
-                    <a:p>
-                      <a:pPr>
-                        <a:defRPr sz="1050">
-                          <a:solidFill>
-                            <a:srgbClr val="1C0812"/>
-                          </a:solidFill>
-                          <a:latin typeface="Arial"/>
-                        </a:defRPr>
-                      </a:pPr>
-                      <a:r>
-                        <a:t>Channel categories</a:t>
-                      </a:r>
-                    </a:p>
-                  </a:txBody>
-                  <a:tcPr marT="30000" marB="30000">
-                    <a:solidFill>
-                      <a:srgbClr val="F6F1F4"/>
-                    </a:solidFill>
-                  </a:tcPr>
-                </a:tc>
-              </a:tr>
-              <a:tr h="274321">
-                <a:tc>
-                  <a:txBody>
-                    <a:bodyPr/>
-                    <a:lstStyle/>
-                    <a:p>
-                      <a:pPr>
-                        <a:defRPr sz="1050">
-                          <a:solidFill>
-                            <a:srgbClr val="1C0812"/>
-                          </a:solidFill>
-                          <a:latin typeface="Arial"/>
-                        </a:defRPr>
-                      </a:pPr>
-                      <a:r>
-                        <a:t>2</a:t>
-                      </a:r>
-                    </a:p>
-                  </a:txBody>
-                  <a:tcPr marT="30000" marB="30000">
-                    <a:solidFill>
-                      <a:srgbClr val="FFFFFF"/>
-                    </a:solidFill>
-                  </a:tcPr>
-                </a:tc>
-                <a:tc>
-                  <a:txBody>
-                    <a:bodyPr/>
-                    <a:lstStyle/>
-                    <a:p>
-                      <a:pPr>
-                        <a:defRPr sz="1050">
-                          <a:solidFill>
-                            <a:srgbClr val="1C0812"/>
-                          </a:solidFill>
-                          <a:latin typeface="Arial"/>
-                        </a:defRPr>
-                      </a:pPr>
-                      <a:r>
-                        <a:t>Channels: OK plays the channel. Channels without a logo show short initials.</a:t>
-                      </a:r>
-                    </a:p>
-                  </a:txBody>
-                  <a:tcPr marT="30000" marB="30000">
-                    <a:solidFill>
-                      <a:srgbClr val="FFFFFF"/>
-                    </a:solidFill>
-                  </a:tcPr>
-                </a:tc>
-              </a:tr>
-            </a:tbl>
-          </a:graphicData>
-        </a:graphic>
-      </p:graphicFrame>
+      <p:pic>
+        <p:nvPicPr>
+          <p:cNvPr id="7" name="Picture 6" descr="tv-sub-es.png"/>
+          <p:cNvPicPr>
+            <a:picLocks noChangeAspect="1"/>
+          </p:cNvPicPr>
+          <p:nvPr/>
+        </p:nvPicPr>
+        <p:blipFill>
+          <a:blip r:embed="rId3"/>
+          <a:stretch>
+            <a:fillRect/>
+          </a:stretch>
+        </p:blipFill>
+        <p:spPr>
+          <a:xfrm>
+            <a:off x="6172200" y="1188720"/>
+            <a:ext cx="5669280" cy="3188970"/>
+          </a:xfrm>
+          <a:prstGeom prst="rect">
+            <a:avLst/>
+          </a:prstGeom>
+        </p:spPr>
+      </p:pic>
       <p:sp>
         <p:nvSpPr>
           <p:cNvPr id="8" name="TextBox 7"/>
@@ -5536,8 +5355,8 @@
         </p:nvSpPr>
         <p:spPr>
           <a:xfrm>
-            <a:off x="365760" y="5166360"/>
-            <a:ext cx="6949440" cy="1463040"/>
+            <a:off x="365760" y="4480560"/>
+            <a:ext cx="5669280" cy="457200"/>
           </a:xfrm>
           <a:prstGeom prst="rect">
             <a:avLst/>
@@ -5554,7 +5373,7 @@
               <a:spcAft>
                 <a:spcPts val="400"/>
               </a:spcAft>
-              <a:defRPr sz="1100" b="0">
+              <a:defRPr sz="1200" b="0">
                 <a:solidFill>
                   <a:srgbClr val="55555F"/>
                 </a:solidFill>
@@ -5562,7 +5381,101 @@
               </a:defRPr>
             </a:pPr>
             <a:r>
-              <a:t>In the player, CH+ / CH− switch to the previous or next channel of the same category.</a:t>
+              <a:t>English subtitles (selected automatically from the preferred language)</a:t>
+            </a:r>
+          </a:p>
+        </p:txBody>
+      </p:sp>
+      <p:sp>
+        <p:nvSpPr>
+          <p:cNvPr id="9" name="TextBox 8"/>
+          <p:cNvSpPr txBox="1"/>
+          <p:nvPr/>
+        </p:nvSpPr>
+        <p:spPr>
+          <a:xfrm>
+            <a:off x="6172200" y="4480560"/>
+            <a:ext cx="5669280" cy="457200"/>
+          </a:xfrm>
+          <a:prstGeom prst="rect">
+            <a:avLst/>
+          </a:prstGeom>
+          <a:noFill/>
+        </p:spPr>
+        <p:txBody>
+          <a:bodyPr wrap="square">
+            <a:spAutoFit/>
+          </a:bodyPr>
+          <a:lstStyle/>
+          <a:p>
+            <a:pPr>
+              <a:spcAft>
+                <a:spcPts val="400"/>
+              </a:spcAft>
+              <a:defRPr sz="1200" b="0">
+                <a:solidFill>
+                  <a:srgbClr val="55555F"/>
+                </a:solidFill>
+                <a:latin typeface="Arial"/>
+              </a:defRPr>
+            </a:pPr>
+            <a:r>
+              <a:t>After pressing BLUE: Spanish subtitles, with an on-screen confirmation</a:t>
+            </a:r>
+          </a:p>
+        </p:txBody>
+      </p:sp>
+      <p:sp>
+        <p:nvSpPr>
+          <p:cNvPr id="10" name="TextBox 9"/>
+          <p:cNvSpPr txBox="1"/>
+          <p:nvPr/>
+        </p:nvSpPr>
+        <p:spPr>
+          <a:xfrm>
+            <a:off x="365760" y="5120640"/>
+            <a:ext cx="11430000" cy="1371600"/>
+          </a:xfrm>
+          <a:prstGeom prst="rect">
+            <a:avLst/>
+          </a:prstGeom>
+          <a:noFill/>
+        </p:spPr>
+        <p:txBody>
+          <a:bodyPr wrap="square">
+            <a:spAutoFit/>
+          </a:bodyPr>
+          <a:lstStyle/>
+          <a:p>
+            <a:pPr>
+              <a:spcAft>
+                <a:spcPts val="400"/>
+              </a:spcAft>
+              <a:defRPr sz="1200" b="0">
+                <a:solidFill>
+                  <a:srgbClr val="55555F"/>
+                </a:solidFill>
+                <a:latin typeface="Arial"/>
+              </a:defRPr>
+            </a:pPr>
+            <a:r>
+              <a:t>Both screenshots were taken on an LG 55SK7900 (2018).</a:t>
+            </a:r>
+          </a:p>
+          <a:p>
+            <a:pPr>
+              <a:spcAft>
+                <a:spcPts val="400"/>
+              </a:spcAft>
+              <a:defRPr sz="1200" b="0">
+                <a:solidFill>
+                  <a:srgbClr val="55555F"/>
+                </a:solidFill>
+                <a:latin typeface="Arial"/>
+              </a:defRPr>
+            </a:pPr>
+            <a:r>
+              <a:t>The subtitle and audio choice made in a series episode is applied automatically to the next episodes.</a:t>
             </a:r>
           </a:p>
         </p:txBody>
@@ -5744,14 +5657,14 @@
               </a:defRPr>
             </a:pPr>
             <a:r>
-              <a:t>6-6 Search</a:t>
+              <a:t>6-5 Live TV</a:t>
             </a:r>
           </a:p>
         </p:txBody>
       </p:sp>
       <p:pic>
         <p:nvPicPr>
-          <p:cNvPr id="6" name="Picture 5" descr="a-search.png"/>
+          <p:cNvPr id="6" name="Picture 5" descr="a-live.png"/>
           <p:cNvPicPr>
             <a:picLocks noChangeAspect="1"/>
           </p:cNvPicPr>
@@ -5783,7 +5696,7 @@
         </p:nvGraphicFramePr>
         <p:xfrm>
           <a:off x="7543800" y="1143000"/>
-          <a:ext cx="4297680" cy="1645919"/>
+          <a:ext cx="4297680" cy="822959"/>
         </p:xfrm>
         <a:graphic>
           <a:graphicData uri="http://schemas.openxmlformats.org/drawingml/2006/table">
@@ -5884,7 +5797,7 @@
                         </a:defRPr>
                       </a:pPr>
                       <a:r>
-                        <a:t>On-screen keyboard: letters and digits</a:t>
+                        <a:t>Channel categories</a:t>
                       </a:r>
                     </a:p>
                   </a:txBody>
@@ -5895,7 +5808,7 @@
                   </a:tcPr>
                 </a:tc>
               </a:tr>
-              <a:tr h="274319">
+              <a:tr h="274321">
                 <a:tc>
                   <a:txBody>
                     <a:bodyPr/>
@@ -5934,163 +5847,13 @@
                         </a:defRPr>
                       </a:pPr>
                       <a:r>
-                        <a:t>Space</a:t>
+                        <a:t>Channels: OK plays the channel. Channels without a logo show short initials.</a:t>
                       </a:r>
                     </a:p>
                   </a:txBody>
                   <a:tcPr marT="30000" marB="30000">
                     <a:solidFill>
                       <a:srgbClr val="FFFFFF"/>
-                    </a:solidFill>
-                  </a:tcPr>
-                </a:tc>
-              </a:tr>
-              <a:tr h="274319">
-                <a:tc>
-                  <a:txBody>
-                    <a:bodyPr/>
-                    <a:lstStyle/>
-                    <a:p>
-                      <a:pPr>
-                        <a:defRPr sz="1050">
-                          <a:solidFill>
-                            <a:srgbClr val="1C0812"/>
-                          </a:solidFill>
-                          <a:latin typeface="Arial"/>
-                        </a:defRPr>
-                      </a:pPr>
-                      <a:r>
-                        <a:t>3</a:t>
-                      </a:r>
-                    </a:p>
-                  </a:txBody>
-                  <a:tcPr marT="30000" marB="30000">
-                    <a:solidFill>
-                      <a:srgbClr val="F6F1F4"/>
-                    </a:solidFill>
-                  </a:tcPr>
-                </a:tc>
-                <a:tc>
-                  <a:txBody>
-                    <a:bodyPr/>
-                    <a:lstStyle/>
-                    <a:p>
-                      <a:pPr>
-                        <a:defRPr sz="1050">
-                          <a:solidFill>
-                            <a:srgbClr val="1C0812"/>
-                          </a:solidFill>
-                          <a:latin typeface="Arial"/>
-                        </a:defRPr>
-                      </a:pPr>
-                      <a:r>
-                        <a:t>Delete the last character</a:t>
-                      </a:r>
-                    </a:p>
-                  </a:txBody>
-                  <a:tcPr marT="30000" marB="30000">
-                    <a:solidFill>
-                      <a:srgbClr val="F6F1F4"/>
-                    </a:solidFill>
-                  </a:tcPr>
-                </a:tc>
-              </a:tr>
-              <a:tr h="274319">
-                <a:tc>
-                  <a:txBody>
-                    <a:bodyPr/>
-                    <a:lstStyle/>
-                    <a:p>
-                      <a:pPr>
-                        <a:defRPr sz="1050">
-                          <a:solidFill>
-                            <a:srgbClr val="1C0812"/>
-                          </a:solidFill>
-                          <a:latin typeface="Arial"/>
-                        </a:defRPr>
-                      </a:pPr>
-                      <a:r>
-                        <a:t>4</a:t>
-                      </a:r>
-                    </a:p>
-                  </a:txBody>
-                  <a:tcPr marT="30000" marB="30000">
-                    <a:solidFill>
-                      <a:srgbClr val="FFFFFF"/>
-                    </a:solidFill>
-                  </a:tcPr>
-                </a:tc>
-                <a:tc>
-                  <a:txBody>
-                    <a:bodyPr/>
-                    <a:lstStyle/>
-                    <a:p>
-                      <a:pPr>
-                        <a:defRPr sz="1050">
-                          <a:solidFill>
-                            <a:srgbClr val="1C0812"/>
-                          </a:solidFill>
-                          <a:latin typeface="Arial"/>
-                        </a:defRPr>
-                      </a:pPr>
-                      <a:r>
-                        <a:t>Clear the search</a:t>
-                      </a:r>
-                    </a:p>
-                  </a:txBody>
-                  <a:tcPr marT="30000" marB="30000">
-                    <a:solidFill>
-                      <a:srgbClr val="FFFFFF"/>
-                    </a:solidFill>
-                  </a:tcPr>
-                </a:tc>
-              </a:tr>
-              <a:tr h="274324">
-                <a:tc>
-                  <a:txBody>
-                    <a:bodyPr/>
-                    <a:lstStyle/>
-                    <a:p>
-                      <a:pPr>
-                        <a:defRPr sz="1050">
-                          <a:solidFill>
-                            <a:srgbClr val="1C0812"/>
-                          </a:solidFill>
-                          <a:latin typeface="Arial"/>
-                        </a:defRPr>
-                      </a:pPr>
-                      <a:r>
-                        <a:t>5</a:t>
-                      </a:r>
-                    </a:p>
-                  </a:txBody>
-                  <a:tcPr marT="30000" marB="30000">
-                    <a:solidFill>
-                      <a:srgbClr val="F6F1F4"/>
-                    </a:solidFill>
-                  </a:tcPr>
-                </a:tc>
-                <a:tc>
-                  <a:txBody>
-                    <a:bodyPr/>
-                    <a:lstStyle/>
-                    <a:p>
-                      <a:pPr>
-                        <a:defRPr sz="1050">
-                          <a:solidFill>
-                            <a:srgbClr val="1C0812"/>
-                          </a:solidFill>
-                          <a:latin typeface="Arial"/>
-                        </a:defRPr>
-                      </a:pPr>
-                      <a:r>
-                        <a:t>Results: movies, series and live channels whose names match</a:t>
-                      </a:r>
-                    </a:p>
-                  </a:txBody>
-                  <a:tcPr marT="30000" marB="30000">
-                    <a:solidFill>
-                      <a:srgbClr val="F6F1F4"/>
                     </a:solidFill>
                   </a:tcPr>
                 </a:tc>
@@ -6133,7 +5896,7 @@
               </a:defRPr>
             </a:pPr>
             <a:r>
-              <a:t>OK on a result opens its detail page (or plays a channel).</a:t>
+              <a:t>In the player, CH+ / CH− switch to the previous or next channel of the same category.</a:t>
             </a:r>
           </a:p>
         </p:txBody>
@@ -6315,14 +6078,14 @@
               </a:defRPr>
             </a:pPr>
             <a:r>
-              <a:t>6-7 Settings</a:t>
+              <a:t>6-6 Search</a:t>
             </a:r>
           </a:p>
         </p:txBody>
       </p:sp>
       <p:pic>
         <p:nvPicPr>
-          <p:cNvPr id="6" name="Picture 5" descr="a-settings.png"/>
+          <p:cNvPr id="6" name="Picture 5" descr="a-search.png"/>
           <p:cNvPicPr>
             <a:picLocks noChangeAspect="1"/>
           </p:cNvPicPr>
@@ -6455,7 +6218,7 @@
                         </a:defRPr>
                       </a:pPr>
                       <a:r>
-                        <a:t>Settings tabs: Profile · Language and subtitles (app language, preferred audio and subtitle language) · Subtitle style · Home (choose and order rows) · IPTV account (sign out) · About (version, license, source code)</a:t>
+                        <a:t>On-screen keyboard: letters and digits</a:t>
                       </a:r>
                     </a:p>
                   </a:txBody>
@@ -6505,7 +6268,7 @@
                         </a:defRPr>
                       </a:pPr>
                       <a:r>
-                        <a:t>Subtitle size</a:t>
+                        <a:t>Space</a:t>
                       </a:r>
                     </a:p>
                   </a:txBody>
@@ -6555,7 +6318,7 @@
                         </a:defRPr>
                       </a:pPr>
                       <a:r>
-                        <a:t>Subtitle color</a:t>
+                        <a:t>Delete the last character</a:t>
                       </a:r>
                     </a:p>
                   </a:txBody>
@@ -6605,7 +6368,7 @@
                         </a:defRPr>
                       </a:pPr>
                       <a:r>
-                        <a:t>Subtitle position</a:t>
+                        <a:t>Clear the search</a:t>
                       </a:r>
                     </a:p>
                   </a:txBody>
@@ -6655,7 +6418,7 @@
                         </a:defRPr>
                       </a:pPr>
                       <a:r>
-                        <a:t>Preview of the selected style</a:t>
+                        <a:t>Results: movies, series and live channels whose names match</a:t>
                       </a:r>
                     </a:p>
                   </a:txBody>
@@ -6704,7 +6467,7 @@
               </a:defRPr>
             </a:pPr>
             <a:r>
-              <a:t>Subtitle style can also be changed while watching, from the Subtitles button in the player.</a:t>
+              <a:t>OK on a result opens its detail page (or plays a channel).</a:t>
             </a:r>
           </a:p>
         </p:txBody>
@@ -6847,7 +6610,7 @@
               </a:defRPr>
             </a:pPr>
             <a:r>
-              <a:t>7. Paid Content</a:t>
+              <a:t>6. Sub Page Description</a:t>
             </a:r>
           </a:p>
         </p:txBody>
@@ -6860,8 +6623,8 @@
         </p:nvSpPr>
         <p:spPr>
           <a:xfrm>
-            <a:off x="731520" y="1371600"/>
-            <a:ext cx="10515600" cy="1828800"/>
+            <a:off x="8229600" y="219456"/>
+            <a:ext cx="3657600" cy="457200"/>
           </a:xfrm>
           <a:prstGeom prst="rect">
             <a:avLst/>
@@ -6874,35 +6637,408 @@
           </a:bodyPr>
           <a:lstStyle/>
           <a:p>
+            <a:pPr algn="r">
+              <a:spcAft>
+                <a:spcPts val="400"/>
+              </a:spcAft>
+              <a:defRPr sz="1200" b="0">
+                <a:solidFill>
+                  <a:srgbClr val="C9CDD4"/>
+                </a:solidFill>
+                <a:latin typeface="Arial"/>
+              </a:defRPr>
+            </a:pPr>
+            <a:r>
+              <a:t>6-7 Settings</a:t>
+            </a:r>
+          </a:p>
+        </p:txBody>
+      </p:sp>
+      <p:pic>
+        <p:nvPicPr>
+          <p:cNvPr id="6" name="Picture 5" descr="a-settings.png"/>
+          <p:cNvPicPr>
+            <a:picLocks noChangeAspect="1"/>
+          </p:cNvPicPr>
+          <p:nvPr/>
+        </p:nvPicPr>
+        <p:blipFill>
+          <a:blip r:embed="rId2"/>
+          <a:stretch>
+            <a:fillRect/>
+          </a:stretch>
+        </p:blipFill>
+        <p:spPr>
+          <a:xfrm>
+            <a:off x="365760" y="1143000"/>
+            <a:ext cx="6949440" cy="3909060"/>
+          </a:xfrm>
+          <a:prstGeom prst="rect">
+            <a:avLst/>
+          </a:prstGeom>
+        </p:spPr>
+      </p:pic>
+      <p:graphicFrame>
+        <p:nvGraphicFramePr>
+          <p:cNvPr id="7" name="Table 6"/>
+          <p:cNvGraphicFramePr>
+            <a:graphicFrameLocks noGrp="1"/>
+          </p:cNvGraphicFramePr>
+          <p:nvPr/>
+        </p:nvGraphicFramePr>
+        <p:xfrm>
+          <a:off x="7543800" y="1143000"/>
+          <a:ext cx="4297680" cy="1645919"/>
+        </p:xfrm>
+        <a:graphic>
+          <a:graphicData uri="http://schemas.openxmlformats.org/drawingml/2006/table">
+            <a:tbl>
+              <a:tblPr firstRow="1" bandRow="1">
+                <a:tableStyleId>{5C22544A-7EE6-4342-B048-85BDC9FD1C3A}</a:tableStyleId>
+              </a:tblPr>
+              <a:tblGrid>
+                <a:gridCol w="502920"/>
+                <a:gridCol w="3794760"/>
+              </a:tblGrid>
+              <a:tr h="274319">
+                <a:tc>
+                  <a:txBody>
+                    <a:bodyPr/>
+                    <a:lstStyle/>
+                    <a:p>
+                      <a:pPr>
+                        <a:defRPr sz="1050" b="1">
+                          <a:solidFill>
+                            <a:srgbClr val="FFFFFF"/>
+                          </a:solidFill>
+                          <a:latin typeface="Arial"/>
+                        </a:defRPr>
+                      </a:pPr>
+                      <a:r>
+                        <a:t>No.</a:t>
+                      </a:r>
+                    </a:p>
+                  </a:txBody>
+                  <a:tcPr>
+                    <a:solidFill>
+                      <a:srgbClr val="E6005C"/>
+                    </a:solidFill>
+                  </a:tcPr>
+                </a:tc>
+                <a:tc>
+                  <a:txBody>
+                    <a:bodyPr/>
+                    <a:lstStyle/>
+                    <a:p>
+                      <a:pPr>
+                        <a:defRPr sz="1050" b="1">
+                          <a:solidFill>
+                            <a:srgbClr val="FFFFFF"/>
+                          </a:solidFill>
+                          <a:latin typeface="Arial"/>
+                        </a:defRPr>
+                      </a:pPr>
+                      <a:r>
+                        <a:t>Description</a:t>
+                      </a:r>
+                    </a:p>
+                  </a:txBody>
+                  <a:tcPr>
+                    <a:solidFill>
+                      <a:srgbClr val="E6005C"/>
+                    </a:solidFill>
+                  </a:tcPr>
+                </a:tc>
+              </a:tr>
+              <a:tr h="274319">
+                <a:tc>
+                  <a:txBody>
+                    <a:bodyPr/>
+                    <a:lstStyle/>
+                    <a:p>
+                      <a:pPr>
+                        <a:defRPr sz="1050">
+                          <a:solidFill>
+                            <a:srgbClr val="1C0812"/>
+                          </a:solidFill>
+                          <a:latin typeface="Arial"/>
+                        </a:defRPr>
+                      </a:pPr>
+                      <a:r>
+                        <a:t>1</a:t>
+                      </a:r>
+                    </a:p>
+                  </a:txBody>
+                  <a:tcPr marT="30000" marB="30000">
+                    <a:solidFill>
+                      <a:srgbClr val="F6F1F4"/>
+                    </a:solidFill>
+                  </a:tcPr>
+                </a:tc>
+                <a:tc>
+                  <a:txBody>
+                    <a:bodyPr/>
+                    <a:lstStyle/>
+                    <a:p>
+                      <a:pPr>
+                        <a:defRPr sz="1050">
+                          <a:solidFill>
+                            <a:srgbClr val="1C0812"/>
+                          </a:solidFill>
+                          <a:latin typeface="Arial"/>
+                        </a:defRPr>
+                      </a:pPr>
+                      <a:r>
+                        <a:t>Settings tabs: Profile · Language and subtitles (app language, preferred audio and subtitle language) · Subtitle style · Home (choose and order rows) · IPTV account (sign out) · About (version, license, source code)</a:t>
+                      </a:r>
+                    </a:p>
+                  </a:txBody>
+                  <a:tcPr marT="30000" marB="30000">
+                    <a:solidFill>
+                      <a:srgbClr val="F6F1F4"/>
+                    </a:solidFill>
+                  </a:tcPr>
+                </a:tc>
+              </a:tr>
+              <a:tr h="274319">
+                <a:tc>
+                  <a:txBody>
+                    <a:bodyPr/>
+                    <a:lstStyle/>
+                    <a:p>
+                      <a:pPr>
+                        <a:defRPr sz="1050">
+                          <a:solidFill>
+                            <a:srgbClr val="1C0812"/>
+                          </a:solidFill>
+                          <a:latin typeface="Arial"/>
+                        </a:defRPr>
+                      </a:pPr>
+                      <a:r>
+                        <a:t>2</a:t>
+                      </a:r>
+                    </a:p>
+                  </a:txBody>
+                  <a:tcPr marT="30000" marB="30000">
+                    <a:solidFill>
+                      <a:srgbClr val="FFFFFF"/>
+                    </a:solidFill>
+                  </a:tcPr>
+                </a:tc>
+                <a:tc>
+                  <a:txBody>
+                    <a:bodyPr/>
+                    <a:lstStyle/>
+                    <a:p>
+                      <a:pPr>
+                        <a:defRPr sz="1050">
+                          <a:solidFill>
+                            <a:srgbClr val="1C0812"/>
+                          </a:solidFill>
+                          <a:latin typeface="Arial"/>
+                        </a:defRPr>
+                      </a:pPr>
+                      <a:r>
+                        <a:t>Subtitle size</a:t>
+                      </a:r>
+                    </a:p>
+                  </a:txBody>
+                  <a:tcPr marT="30000" marB="30000">
+                    <a:solidFill>
+                      <a:srgbClr val="FFFFFF"/>
+                    </a:solidFill>
+                  </a:tcPr>
+                </a:tc>
+              </a:tr>
+              <a:tr h="274319">
+                <a:tc>
+                  <a:txBody>
+                    <a:bodyPr/>
+                    <a:lstStyle/>
+                    <a:p>
+                      <a:pPr>
+                        <a:defRPr sz="1050">
+                          <a:solidFill>
+                            <a:srgbClr val="1C0812"/>
+                          </a:solidFill>
+                          <a:latin typeface="Arial"/>
+                        </a:defRPr>
+                      </a:pPr>
+                      <a:r>
+                        <a:t>3</a:t>
+                      </a:r>
+                    </a:p>
+                  </a:txBody>
+                  <a:tcPr marT="30000" marB="30000">
+                    <a:solidFill>
+                      <a:srgbClr val="F6F1F4"/>
+                    </a:solidFill>
+                  </a:tcPr>
+                </a:tc>
+                <a:tc>
+                  <a:txBody>
+                    <a:bodyPr/>
+                    <a:lstStyle/>
+                    <a:p>
+                      <a:pPr>
+                        <a:defRPr sz="1050">
+                          <a:solidFill>
+                            <a:srgbClr val="1C0812"/>
+                          </a:solidFill>
+                          <a:latin typeface="Arial"/>
+                        </a:defRPr>
+                      </a:pPr>
+                      <a:r>
+                        <a:t>Subtitle color</a:t>
+                      </a:r>
+                    </a:p>
+                  </a:txBody>
+                  <a:tcPr marT="30000" marB="30000">
+                    <a:solidFill>
+                      <a:srgbClr val="F6F1F4"/>
+                    </a:solidFill>
+                  </a:tcPr>
+                </a:tc>
+              </a:tr>
+              <a:tr h="274319">
+                <a:tc>
+                  <a:txBody>
+                    <a:bodyPr/>
+                    <a:lstStyle/>
+                    <a:p>
+                      <a:pPr>
+                        <a:defRPr sz="1050">
+                          <a:solidFill>
+                            <a:srgbClr val="1C0812"/>
+                          </a:solidFill>
+                          <a:latin typeface="Arial"/>
+                        </a:defRPr>
+                      </a:pPr>
+                      <a:r>
+                        <a:t>4</a:t>
+                      </a:r>
+                    </a:p>
+                  </a:txBody>
+                  <a:tcPr marT="30000" marB="30000">
+                    <a:solidFill>
+                      <a:srgbClr val="FFFFFF"/>
+                    </a:solidFill>
+                  </a:tcPr>
+                </a:tc>
+                <a:tc>
+                  <a:txBody>
+                    <a:bodyPr/>
+                    <a:lstStyle/>
+                    <a:p>
+                      <a:pPr>
+                        <a:defRPr sz="1050">
+                          <a:solidFill>
+                            <a:srgbClr val="1C0812"/>
+                          </a:solidFill>
+                          <a:latin typeface="Arial"/>
+                        </a:defRPr>
+                      </a:pPr>
+                      <a:r>
+                        <a:t>Subtitle position</a:t>
+                      </a:r>
+                    </a:p>
+                  </a:txBody>
+                  <a:tcPr marT="30000" marB="30000">
+                    <a:solidFill>
+                      <a:srgbClr val="FFFFFF"/>
+                    </a:solidFill>
+                  </a:tcPr>
+                </a:tc>
+              </a:tr>
+              <a:tr h="274324">
+                <a:tc>
+                  <a:txBody>
+                    <a:bodyPr/>
+                    <a:lstStyle/>
+                    <a:p>
+                      <a:pPr>
+                        <a:defRPr sz="1050">
+                          <a:solidFill>
+                            <a:srgbClr val="1C0812"/>
+                          </a:solidFill>
+                          <a:latin typeface="Arial"/>
+                        </a:defRPr>
+                      </a:pPr>
+                      <a:r>
+                        <a:t>5</a:t>
+                      </a:r>
+                    </a:p>
+                  </a:txBody>
+                  <a:tcPr marT="30000" marB="30000">
+                    <a:solidFill>
+                      <a:srgbClr val="F6F1F4"/>
+                    </a:solidFill>
+                  </a:tcPr>
+                </a:tc>
+                <a:tc>
+                  <a:txBody>
+                    <a:bodyPr/>
+                    <a:lstStyle/>
+                    <a:p>
+                      <a:pPr>
+                        <a:defRPr sz="1050">
+                          <a:solidFill>
+                            <a:srgbClr val="1C0812"/>
+                          </a:solidFill>
+                          <a:latin typeface="Arial"/>
+                        </a:defRPr>
+                      </a:pPr>
+                      <a:r>
+                        <a:t>Preview of the selected style</a:t>
+                      </a:r>
+                    </a:p>
+                  </a:txBody>
+                  <a:tcPr marT="30000" marB="30000">
+                    <a:solidFill>
+                      <a:srgbClr val="F6F1F4"/>
+                    </a:solidFill>
+                  </a:tcPr>
+                </a:tc>
+              </a:tr>
+            </a:tbl>
+          </a:graphicData>
+        </a:graphic>
+      </p:graphicFrame>
+      <p:sp>
+        <p:nvSpPr>
+          <p:cNvPr id="8" name="TextBox 7"/>
+          <p:cNvSpPr txBox="1"/>
+          <p:nvPr/>
+        </p:nvSpPr>
+        <p:spPr>
+          <a:xfrm>
+            <a:off x="365760" y="5166360"/>
+            <a:ext cx="6949440" cy="1463040"/>
+          </a:xfrm>
+          <a:prstGeom prst="rect">
+            <a:avLst/>
+          </a:prstGeom>
+          <a:noFill/>
+        </p:spPr>
+        <p:txBody>
+          <a:bodyPr wrap="square">
+            <a:spAutoFit/>
+          </a:bodyPr>
+          <a:lstStyle/>
+          <a:p>
             <a:pPr>
               <a:spcAft>
                 <a:spcPts val="400"/>
               </a:spcAft>
-              <a:defRPr sz="2000" b="0">
+              <a:defRPr sz="1100" b="0">
                 <a:solidFill>
-                  <a:srgbClr val="1C0812"/>
+                  <a:srgbClr val="55555F"/>
                 </a:solidFill>
                 <a:latin typeface="Arial"/>
               </a:defRPr>
             </a:pPr>
             <a:r>
-              <a:t>None.</a:t>
-            </a:r>
-          </a:p>
-          <a:p>
-            <a:pPr>
-              <a:spcAft>
-                <a:spcPts val="400"/>
-              </a:spcAft>
-              <a:defRPr sz="2000" b="0">
-                <a:solidFill>
-                  <a:srgbClr val="1C0812"/>
-                </a:solidFill>
-                <a:latin typeface="Arial"/>
-              </a:defRPr>
-            </a:pPr>
-            <a:r>
-              <a:t>Velvo is free. It has no in-app purchases, no payment methods and no paid content, so no test credit cards or voucher codes are needed.</a:t>
+              <a:t>Subtitle style can also be changed while watching, from the Subtitles button in the player.</a:t>
             </a:r>
           </a:p>
         </p:txBody>
@@ -7045,7 +7181,7 @@
               </a:defRPr>
             </a:pPr>
             <a:r>
-              <a:t>8. In-App Ad</a:t>
+              <a:t>7. Paid Content</a:t>
             </a:r>
           </a:p>
         </p:txBody>
@@ -7100,7 +7236,7 @@
               </a:defRPr>
             </a:pPr>
             <a:r>
-              <a:t>Velvo shows no advertisements (no banner or video ads).</a:t>
+              <a:t>Velvo is free. It has no in-app purchases, no payment methods and no paid content, so no test credit cards or voucher codes are needed.</a:t>
             </a:r>
           </a:p>
         </p:txBody>
@@ -7114,6 +7250,204 @@
 </file>
 
 <file path=ppt/slides/slide18.xml><?xml version="1.0" encoding="utf-8"?>
+<p:sld xmlns:a="http://schemas.openxmlformats.org/drawingml/2006/main" xmlns:p="http://schemas.openxmlformats.org/presentationml/2006/main" xmlns:r="http://schemas.openxmlformats.org/officeDocument/2006/relationships">
+  <p:cSld>
+    <p:spTree>
+      <p:nvGrpSpPr>
+        <p:cNvPr id="1" name=""/>
+        <p:cNvGrpSpPr/>
+        <p:nvPr/>
+      </p:nvGrpSpPr>
+      <p:grpSpPr/>
+      <p:sp>
+        <p:nvSpPr>
+          <p:cNvPr id="2" name="Rectangle 1"/>
+          <p:cNvSpPr/>
+          <p:nvPr/>
+        </p:nvSpPr>
+        <p:spPr>
+          <a:xfrm>
+            <a:off x="0" y="0"/>
+            <a:ext cx="12191695" cy="822960"/>
+          </a:xfrm>
+          <a:prstGeom prst="rect">
+            <a:avLst/>
+          </a:prstGeom>
+          <a:solidFill>
+            <a:srgbClr val="1C0812"/>
+          </a:solidFill>
+          <a:ln>
+            <a:noFill/>
+          </a:ln>
+        </p:spPr>
+        <p:style>
+          <a:lnRef idx="1">
+            <a:schemeClr val="accent1"/>
+          </a:lnRef>
+          <a:fillRef idx="3">
+            <a:schemeClr val="accent1"/>
+          </a:fillRef>
+          <a:effectRef idx="2">
+            <a:schemeClr val="accent1"/>
+          </a:effectRef>
+          <a:fontRef idx="minor">
+            <a:schemeClr val="lt1"/>
+          </a:fontRef>
+        </p:style>
+        <p:txBody>
+          <a:bodyPr rtlCol="0" anchor="ctr"/>
+          <a:lstStyle/>
+          <a:p>
+            <a:pPr algn="ctr"/>
+          </a:p>
+        </p:txBody>
+      </p:sp>
+      <p:sp>
+        <p:nvSpPr>
+          <p:cNvPr id="3" name="Rectangle 2"/>
+          <p:cNvSpPr/>
+          <p:nvPr/>
+        </p:nvSpPr>
+        <p:spPr>
+          <a:xfrm>
+            <a:off x="0" y="822960"/>
+            <a:ext cx="12191695" cy="54864"/>
+          </a:xfrm>
+          <a:prstGeom prst="rect">
+            <a:avLst/>
+          </a:prstGeom>
+          <a:solidFill>
+            <a:srgbClr val="E6005C"/>
+          </a:solidFill>
+          <a:ln>
+            <a:noFill/>
+          </a:ln>
+        </p:spPr>
+        <p:style>
+          <a:lnRef idx="1">
+            <a:schemeClr val="accent1"/>
+          </a:lnRef>
+          <a:fillRef idx="3">
+            <a:schemeClr val="accent1"/>
+          </a:fillRef>
+          <a:effectRef idx="2">
+            <a:schemeClr val="accent1"/>
+          </a:effectRef>
+          <a:fontRef idx="minor">
+            <a:schemeClr val="lt1"/>
+          </a:fontRef>
+        </p:style>
+        <p:txBody>
+          <a:bodyPr rtlCol="0" anchor="ctr"/>
+          <a:lstStyle/>
+          <a:p>
+            <a:pPr algn="ctr"/>
+          </a:p>
+        </p:txBody>
+      </p:sp>
+      <p:sp>
+        <p:nvSpPr>
+          <p:cNvPr id="4" name="TextBox 3"/>
+          <p:cNvSpPr txBox="1"/>
+          <p:nvPr/>
+        </p:nvSpPr>
+        <p:spPr>
+          <a:xfrm>
+            <a:off x="365760" y="128016"/>
+            <a:ext cx="9144000" cy="548640"/>
+          </a:xfrm>
+          <a:prstGeom prst="rect">
+            <a:avLst/>
+          </a:prstGeom>
+          <a:noFill/>
+        </p:spPr>
+        <p:txBody>
+          <a:bodyPr wrap="square">
+            <a:spAutoFit/>
+          </a:bodyPr>
+          <a:lstStyle/>
+          <a:p>
+            <a:pPr>
+              <a:spcAft>
+                <a:spcPts val="400"/>
+              </a:spcAft>
+              <a:defRPr sz="2400" b="1">
+                <a:solidFill>
+                  <a:srgbClr val="FFFFFF"/>
+                </a:solidFill>
+                <a:latin typeface="Arial"/>
+              </a:defRPr>
+            </a:pPr>
+            <a:r>
+              <a:t>8. In-App Ad</a:t>
+            </a:r>
+          </a:p>
+        </p:txBody>
+      </p:sp>
+      <p:sp>
+        <p:nvSpPr>
+          <p:cNvPr id="5" name="TextBox 4"/>
+          <p:cNvSpPr txBox="1"/>
+          <p:nvPr/>
+        </p:nvSpPr>
+        <p:spPr>
+          <a:xfrm>
+            <a:off x="731520" y="1371600"/>
+            <a:ext cx="10515600" cy="1828800"/>
+          </a:xfrm>
+          <a:prstGeom prst="rect">
+            <a:avLst/>
+          </a:prstGeom>
+          <a:noFill/>
+        </p:spPr>
+        <p:txBody>
+          <a:bodyPr wrap="square">
+            <a:spAutoFit/>
+          </a:bodyPr>
+          <a:lstStyle/>
+          <a:p>
+            <a:pPr>
+              <a:spcAft>
+                <a:spcPts val="400"/>
+              </a:spcAft>
+              <a:defRPr sz="2000" b="0">
+                <a:solidFill>
+                  <a:srgbClr val="1C0812"/>
+                </a:solidFill>
+                <a:latin typeface="Arial"/>
+              </a:defRPr>
+            </a:pPr>
+            <a:r>
+              <a:t>None.</a:t>
+            </a:r>
+          </a:p>
+          <a:p>
+            <a:pPr>
+              <a:spcAft>
+                <a:spcPts val="400"/>
+              </a:spcAft>
+              <a:defRPr sz="2000" b="0">
+                <a:solidFill>
+                  <a:srgbClr val="1C0812"/>
+                </a:solidFill>
+                <a:latin typeface="Arial"/>
+              </a:defRPr>
+            </a:pPr>
+            <a:r>
+              <a:t>Velvo shows no advertisements (no banner or video ads).</a:t>
+            </a:r>
+          </a:p>
+        </p:txBody>
+      </p:sp>
+    </p:spTree>
+  </p:cSld>
+  <p:clrMapOvr>
+    <a:masterClrMapping/>
+  </p:clrMapOvr>
+</p:sld>
+</file>
+
+<file path=ppt/slides/slide19.xml><?xml version="1.0" encoding="utf-8"?>
 <p:sld xmlns:a="http://schemas.openxmlformats.org/drawingml/2006/main" xmlns:p="http://schemas.openxmlformats.org/presentationml/2006/main" xmlns:r="http://schemas.openxmlformats.org/officeDocument/2006/relationships">
   <p:cSld>
     <p:spTree>

</xml_diff>